<commit_message>
Subcategory- working with index page
</commit_message>
<xml_diff>
--- a/.lessons/56 Category, Subcategory and Child Category Setup/8 Subcategory- working with index page/1.pptx
+++ b/.lessons/56 Category, Subcategory and Child Category Setup/8 Subcategory- working with index page/1.pptx
@@ -6,8 +6,16 @@
   </p:sldMasterIdLst>
   <p:sldIdLst>
     <p:sldId id="413" r:id="rId2"/>
-    <p:sldId id="414" r:id="rId3"/>
-    <p:sldId id="400" r:id="rId4"/>
+    <p:sldId id="415" r:id="rId3"/>
+    <p:sldId id="416" r:id="rId4"/>
+    <p:sldId id="414" r:id="rId5"/>
+    <p:sldId id="417" r:id="rId6"/>
+    <p:sldId id="418" r:id="rId7"/>
+    <p:sldId id="419" r:id="rId8"/>
+    <p:sldId id="420" r:id="rId9"/>
+    <p:sldId id="421" r:id="rId10"/>
+    <p:sldId id="422" r:id="rId11"/>
+    <p:sldId id="400" r:id="rId12"/>
   </p:sldIdLst>
   <p:sldSz cx="12192000" cy="6858000"/>
   <p:notesSz cx="6858000" cy="9144000"/>
@@ -261,7 +269,7 @@
           <a:p>
             <a:fld id="{3E102D2E-813C-461C-9963-687A650C48C0}" type="datetimeFigureOut">
               <a:rPr lang="en-US" smtClean="0"/>
-              <a:t>6/26/2025</a:t>
+              <a:t>8/19/2025</a:t>
             </a:fld>
             <a:endParaRPr lang="en-US"/>
           </a:p>
@@ -459,7 +467,7 @@
           <a:p>
             <a:fld id="{3E102D2E-813C-461C-9963-687A650C48C0}" type="datetimeFigureOut">
               <a:rPr lang="en-US" smtClean="0"/>
-              <a:t>6/26/2025</a:t>
+              <a:t>8/19/2025</a:t>
             </a:fld>
             <a:endParaRPr lang="en-US"/>
           </a:p>
@@ -667,7 +675,7 @@
           <a:p>
             <a:fld id="{3E102D2E-813C-461C-9963-687A650C48C0}" type="datetimeFigureOut">
               <a:rPr lang="en-US" smtClean="0"/>
-              <a:t>6/26/2025</a:t>
+              <a:t>8/19/2025</a:t>
             </a:fld>
             <a:endParaRPr lang="en-US"/>
           </a:p>
@@ -865,7 +873,7 @@
           <a:p>
             <a:fld id="{3E102D2E-813C-461C-9963-687A650C48C0}" type="datetimeFigureOut">
               <a:rPr lang="en-US" smtClean="0"/>
-              <a:t>6/26/2025</a:t>
+              <a:t>8/19/2025</a:t>
             </a:fld>
             <a:endParaRPr lang="en-US"/>
           </a:p>
@@ -1140,7 +1148,7 @@
           <a:p>
             <a:fld id="{3E102D2E-813C-461C-9963-687A650C48C0}" type="datetimeFigureOut">
               <a:rPr lang="en-US" smtClean="0"/>
-              <a:t>6/26/2025</a:t>
+              <a:t>8/19/2025</a:t>
             </a:fld>
             <a:endParaRPr lang="en-US"/>
           </a:p>
@@ -1405,7 +1413,7 @@
           <a:p>
             <a:fld id="{3E102D2E-813C-461C-9963-687A650C48C0}" type="datetimeFigureOut">
               <a:rPr lang="en-US" smtClean="0"/>
-              <a:t>6/26/2025</a:t>
+              <a:t>8/19/2025</a:t>
             </a:fld>
             <a:endParaRPr lang="en-US"/>
           </a:p>
@@ -1817,7 +1825,7 @@
           <a:p>
             <a:fld id="{3E102D2E-813C-461C-9963-687A650C48C0}" type="datetimeFigureOut">
               <a:rPr lang="en-US" smtClean="0"/>
-              <a:t>6/26/2025</a:t>
+              <a:t>8/19/2025</a:t>
             </a:fld>
             <a:endParaRPr lang="en-US"/>
           </a:p>
@@ -1958,7 +1966,7 @@
           <a:p>
             <a:fld id="{3E102D2E-813C-461C-9963-687A650C48C0}" type="datetimeFigureOut">
               <a:rPr lang="en-US" smtClean="0"/>
-              <a:t>6/26/2025</a:t>
+              <a:t>8/19/2025</a:t>
             </a:fld>
             <a:endParaRPr lang="en-US"/>
           </a:p>
@@ -2071,7 +2079,7 @@
           <a:p>
             <a:fld id="{3E102D2E-813C-461C-9963-687A650C48C0}" type="datetimeFigureOut">
               <a:rPr lang="en-US" smtClean="0"/>
-              <a:t>6/26/2025</a:t>
+              <a:t>8/19/2025</a:t>
             </a:fld>
             <a:endParaRPr lang="en-US"/>
           </a:p>
@@ -2382,7 +2390,7 @@
           <a:p>
             <a:fld id="{3E102D2E-813C-461C-9963-687A650C48C0}" type="datetimeFigureOut">
               <a:rPr lang="en-US" smtClean="0"/>
-              <a:t>6/26/2025</a:t>
+              <a:t>8/19/2025</a:t>
             </a:fld>
             <a:endParaRPr lang="en-US"/>
           </a:p>
@@ -2670,7 +2678,7 @@
           <a:p>
             <a:fld id="{3E102D2E-813C-461C-9963-687A650C48C0}" type="datetimeFigureOut">
               <a:rPr lang="en-US" smtClean="0"/>
-              <a:t>6/26/2025</a:t>
+              <a:t>8/19/2025</a:t>
             </a:fld>
             <a:endParaRPr lang="en-US"/>
           </a:p>
@@ -2911,7 +2919,7 @@
           <a:p>
             <a:fld id="{3E102D2E-813C-461C-9963-687A650C48C0}" type="datetimeFigureOut">
               <a:rPr lang="en-US" smtClean="0"/>
-              <a:t>6/26/2025</a:t>
+              <a:t>8/19/2025</a:t>
             </a:fld>
             <a:endParaRPr lang="en-US"/>
           </a:p>
@@ -3369,21 +3377,84 @@
               <a:buNone/>
             </a:pPr>
             <a:r>
-              <a:rPr kumimoji="0" lang="en-US" altLang="en-US" sz="1300" b="0" i="0" u="none" strike="noStrike" cap="none" normalizeH="0" baseline="0">
-                <a:ln>
-                  <a:noFill/>
-                </a:ln>
-                <a:solidFill>
-                  <a:schemeClr val="tx1"/>
-                </a:solidFill>
-                <a:effectLst/>
-                <a:latin typeface="Arial" panose="020B0604020202020204" pitchFamily="34" charset="0"/>
-              </a:rPr>
-              <a:t>.</a:t>
-            </a:r>
-          </a:p>
-        </p:txBody>
-      </p:sp>
+              <a:rPr lang="en-US" altLang="en-US" sz="1300" b="1">
+                <a:latin typeface="Arial" panose="020B0604020202020204" pitchFamily="34" charset="0"/>
+              </a:rPr>
+              <a:t>SubCategory </a:t>
+            </a:r>
+            <a:r>
+              <a:rPr lang="az-Latn-AZ" altLang="en-US" sz="1300">
+                <a:latin typeface="Arial" panose="020B0604020202020204" pitchFamily="34" charset="0"/>
+              </a:rPr>
+              <a:t>üçün </a:t>
+            </a:r>
+            <a:r>
+              <a:rPr lang="az-Latn-AZ" altLang="en-US" sz="1300" b="1">
+                <a:latin typeface="Arial" panose="020B0604020202020204" pitchFamily="34" charset="0"/>
+              </a:rPr>
+              <a:t>controller</a:t>
+            </a:r>
+            <a:r>
+              <a:rPr lang="az-Latn-AZ" altLang="en-US" sz="1300">
+                <a:latin typeface="Arial" panose="020B0604020202020204" pitchFamily="34" charset="0"/>
+              </a:rPr>
+              <a:t> və </a:t>
+            </a:r>
+            <a:r>
+              <a:rPr lang="az-Latn-AZ" altLang="en-US" sz="1300" b="1">
+                <a:latin typeface="Arial" panose="020B0604020202020204" pitchFamily="34" charset="0"/>
+              </a:rPr>
+              <a:t>model</a:t>
+            </a:r>
+            <a:r>
+              <a:rPr lang="az-Latn-AZ" altLang="en-US" sz="1300">
+                <a:latin typeface="Arial" panose="020B0604020202020204" pitchFamily="34" charset="0"/>
+              </a:rPr>
+              <a:t> yaradırıq.</a:t>
+            </a:r>
+            <a:endParaRPr kumimoji="0" lang="en-US" altLang="en-US" sz="1300" b="0" i="0" u="none" strike="noStrike" cap="none" normalizeH="0" baseline="0">
+              <a:ln>
+                <a:noFill/>
+              </a:ln>
+              <a:solidFill>
+                <a:schemeClr val="tx1"/>
+              </a:solidFill>
+              <a:effectLst/>
+              <a:latin typeface="Arial" panose="020B0604020202020204" pitchFamily="34" charset="0"/>
+            </a:endParaRPr>
+          </a:p>
+        </p:txBody>
+      </p:sp>
+      <p:pic>
+        <p:nvPicPr>
+          <p:cNvPr id="4" name="Picture 3">
+            <a:extLst>
+              <a:ext uri="{FF2B5EF4-FFF2-40B4-BE49-F238E27FC236}">
+                <a16:creationId xmlns:a16="http://schemas.microsoft.com/office/drawing/2014/main" id="{3E0F5337-09D5-A3EF-D7F1-360E0C506AB8}"/>
+              </a:ext>
+            </a:extLst>
+          </p:cNvPr>
+          <p:cNvPicPr>
+            <a:picLocks noChangeAspect="1"/>
+          </p:cNvPicPr>
+          <p:nvPr/>
+        </p:nvPicPr>
+        <p:blipFill>
+          <a:blip r:embed="rId2"/>
+          <a:stretch>
+            <a:fillRect/>
+          </a:stretch>
+        </p:blipFill>
+        <p:spPr>
+          <a:xfrm>
+            <a:off x="0" y="4298887"/>
+            <a:ext cx="10488489" cy="2524477"/>
+          </a:xfrm>
+          <a:prstGeom prst="rect">
+            <a:avLst/>
+          </a:prstGeom>
+        </p:spPr>
+      </p:pic>
     </p:spTree>
     <p:extLst>
       <p:ext uri="{BB962C8B-B14F-4D97-AF65-F5344CB8AC3E}">
@@ -3397,7 +3468,513 @@
 </p:sld>
 </file>
 
+<file path=ppt/slides/slide10.xml><?xml version="1.0" encoding="utf-8"?>
+<p:sld xmlns:a="http://schemas.openxmlformats.org/drawingml/2006/main" xmlns:r="http://schemas.openxmlformats.org/officeDocument/2006/relationships" xmlns:p="http://schemas.openxmlformats.org/presentationml/2006/main">
+  <p:cSld>
+    <p:spTree>
+      <p:nvGrpSpPr>
+        <p:cNvPr id="1" name="">
+          <a:extLst>
+            <a:ext uri="{FF2B5EF4-FFF2-40B4-BE49-F238E27FC236}">
+              <a16:creationId xmlns:a16="http://schemas.microsoft.com/office/drawing/2014/main" id="{7A8B3941-1D82-4E0C-1CBB-C08E16B505E4}"/>
+            </a:ext>
+          </a:extLst>
+        </p:cNvPr>
+        <p:cNvGrpSpPr/>
+        <p:nvPr/>
+      </p:nvGrpSpPr>
+      <p:grpSpPr>
+        <a:xfrm>
+          <a:off x="0" y="0"/>
+          <a:ext cx="0" cy="0"/>
+          <a:chOff x="0" y="0"/>
+          <a:chExt cx="0" cy="0"/>
+        </a:xfrm>
+      </p:grpSpPr>
+      <p:sp>
+        <p:nvSpPr>
+          <p:cNvPr id="3" name="TextBox 2">
+            <a:extLst>
+              <a:ext uri="{FF2B5EF4-FFF2-40B4-BE49-F238E27FC236}">
+                <a16:creationId xmlns:a16="http://schemas.microsoft.com/office/drawing/2014/main" id="{6AA102C6-550A-0FF4-E492-498667FA69FE}"/>
+              </a:ext>
+            </a:extLst>
+          </p:cNvPr>
+          <p:cNvSpPr txBox="1"/>
+          <p:nvPr/>
+        </p:nvSpPr>
+        <p:spPr>
+          <a:xfrm>
+            <a:off x="217714" y="255046"/>
+            <a:ext cx="11756571" cy="355354"/>
+          </a:xfrm>
+          <a:prstGeom prst="rect">
+            <a:avLst/>
+          </a:prstGeom>
+          <a:noFill/>
+        </p:spPr>
+        <p:txBody>
+          <a:bodyPr wrap="square">
+            <a:spAutoFit/>
+          </a:bodyPr>
+          <a:lstStyle/>
+          <a:p>
+            <a:pPr>
+              <a:lnSpc>
+                <a:spcPct val="150000"/>
+              </a:lnSpc>
+              <a:buNone/>
+            </a:pPr>
+            <a:r>
+              <a:rPr lang="az-Latn-AZ" altLang="en-US" sz="1300">
+                <a:latin typeface="Arial" panose="020B0604020202020204" pitchFamily="34" charset="0"/>
+              </a:rPr>
+              <a:t>DB</a:t>
+            </a:r>
+            <a:endParaRPr kumimoji="0" lang="en-US" altLang="en-US" sz="1300" b="0" i="0" u="none" strike="noStrike" cap="none" normalizeH="0" baseline="0">
+              <a:ln>
+                <a:noFill/>
+              </a:ln>
+              <a:solidFill>
+                <a:schemeClr val="tx1"/>
+              </a:solidFill>
+              <a:effectLst/>
+              <a:latin typeface="Arial" panose="020B0604020202020204" pitchFamily="34" charset="0"/>
+            </a:endParaRPr>
+          </a:p>
+        </p:txBody>
+      </p:sp>
+      <p:pic>
+        <p:nvPicPr>
+          <p:cNvPr id="4" name="Picture 3">
+            <a:extLst>
+              <a:ext uri="{FF2B5EF4-FFF2-40B4-BE49-F238E27FC236}">
+                <a16:creationId xmlns:a16="http://schemas.microsoft.com/office/drawing/2014/main" id="{9056C15E-1D94-43B0-31C9-C8E9C88123E4}"/>
+              </a:ext>
+            </a:extLst>
+          </p:cNvPr>
+          <p:cNvPicPr>
+            <a:picLocks noChangeAspect="1"/>
+          </p:cNvPicPr>
+          <p:nvPr/>
+        </p:nvPicPr>
+        <p:blipFill>
+          <a:blip r:embed="rId2"/>
+          <a:stretch>
+            <a:fillRect/>
+          </a:stretch>
+        </p:blipFill>
+        <p:spPr>
+          <a:xfrm>
+            <a:off x="535232" y="1857155"/>
+            <a:ext cx="10955279" cy="3143689"/>
+          </a:xfrm>
+          <a:prstGeom prst="rect">
+            <a:avLst/>
+          </a:prstGeom>
+          <a:ln w="38100" cap="sq">
+            <a:solidFill>
+              <a:srgbClr val="000000"/>
+            </a:solidFill>
+            <a:prstDash val="solid"/>
+            <a:miter lim="800000"/>
+          </a:ln>
+          <a:effectLst>
+            <a:outerShdw blurRad="50800" dist="38100" dir="2700000" algn="tl" rotWithShape="0">
+              <a:srgbClr val="000000">
+                <a:alpha val="43000"/>
+              </a:srgbClr>
+            </a:outerShdw>
+          </a:effectLst>
+        </p:spPr>
+      </p:pic>
+    </p:spTree>
+    <p:extLst>
+      <p:ext uri="{BB962C8B-B14F-4D97-AF65-F5344CB8AC3E}">
+        <p14:creationId xmlns:p14="http://schemas.microsoft.com/office/powerpoint/2010/main" val="2554108523"/>
+      </p:ext>
+    </p:extLst>
+  </p:cSld>
+  <p:clrMapOvr>
+    <a:masterClrMapping/>
+  </p:clrMapOvr>
+</p:sld>
+</file>
+
+<file path=ppt/slides/slide11.xml><?xml version="1.0" encoding="utf-8"?>
+<p:sld xmlns:a="http://schemas.openxmlformats.org/drawingml/2006/main" xmlns:r="http://schemas.openxmlformats.org/officeDocument/2006/relationships" xmlns:p="http://schemas.openxmlformats.org/presentationml/2006/main">
+  <p:cSld>
+    <p:spTree>
+      <p:nvGrpSpPr>
+        <p:cNvPr id="1" name="">
+          <a:extLst>
+            <a:ext uri="{FF2B5EF4-FFF2-40B4-BE49-F238E27FC236}">
+              <a16:creationId xmlns:a16="http://schemas.microsoft.com/office/drawing/2014/main" id="{ECE25D7D-A080-F22B-7E8D-36EC827289A1}"/>
+            </a:ext>
+          </a:extLst>
+        </p:cNvPr>
+        <p:cNvGrpSpPr/>
+        <p:nvPr/>
+      </p:nvGrpSpPr>
+      <p:grpSpPr>
+        <a:xfrm>
+          <a:off x="0" y="0"/>
+          <a:ext cx="0" cy="0"/>
+          <a:chOff x="0" y="0"/>
+          <a:chExt cx="0" cy="0"/>
+        </a:xfrm>
+      </p:grpSpPr>
+      <p:sp>
+        <p:nvSpPr>
+          <p:cNvPr id="3" name="TextBox 2">
+            <a:extLst>
+              <a:ext uri="{FF2B5EF4-FFF2-40B4-BE49-F238E27FC236}">
+                <a16:creationId xmlns:a16="http://schemas.microsoft.com/office/drawing/2014/main" id="{E33F16A3-A6E8-401E-847B-09570DC6E4CB}"/>
+              </a:ext>
+            </a:extLst>
+          </p:cNvPr>
+          <p:cNvSpPr txBox="1"/>
+          <p:nvPr/>
+        </p:nvSpPr>
+        <p:spPr>
+          <a:xfrm>
+            <a:off x="217714" y="255046"/>
+            <a:ext cx="11756571" cy="355354"/>
+          </a:xfrm>
+          <a:prstGeom prst="rect">
+            <a:avLst/>
+          </a:prstGeom>
+          <a:noFill/>
+        </p:spPr>
+        <p:txBody>
+          <a:bodyPr wrap="square">
+            <a:spAutoFit/>
+          </a:bodyPr>
+          <a:lstStyle/>
+          <a:p>
+            <a:pPr>
+              <a:lnSpc>
+                <a:spcPct val="150000"/>
+              </a:lnSpc>
+              <a:buNone/>
+            </a:pPr>
+            <a:r>
+              <a:rPr kumimoji="0" lang="en-US" altLang="en-US" sz="1300" b="0" i="0" u="none" strike="noStrike" cap="none" normalizeH="0" baseline="0">
+                <a:ln>
+                  <a:noFill/>
+                </a:ln>
+                <a:solidFill>
+                  <a:schemeClr val="tx1"/>
+                </a:solidFill>
+                <a:effectLst/>
+                <a:latin typeface="Arial" panose="020B0604020202020204" pitchFamily="34" charset="0"/>
+              </a:rPr>
+              <a:t>.</a:t>
+            </a:r>
+          </a:p>
+        </p:txBody>
+      </p:sp>
+    </p:spTree>
+    <p:extLst>
+      <p:ext uri="{BB962C8B-B14F-4D97-AF65-F5344CB8AC3E}">
+        <p14:creationId xmlns:p14="http://schemas.microsoft.com/office/powerpoint/2010/main" val="3095838342"/>
+      </p:ext>
+    </p:extLst>
+  </p:cSld>
+  <p:clrMapOvr>
+    <a:masterClrMapping/>
+  </p:clrMapOvr>
+</p:sld>
+</file>
+
 <file path=ppt/slides/slide2.xml><?xml version="1.0" encoding="utf-8"?>
+<p:sld xmlns:a="http://schemas.openxmlformats.org/drawingml/2006/main" xmlns:r="http://schemas.openxmlformats.org/officeDocument/2006/relationships" xmlns:p="http://schemas.openxmlformats.org/presentationml/2006/main">
+  <p:cSld>
+    <p:spTree>
+      <p:nvGrpSpPr>
+        <p:cNvPr id="1" name="">
+          <a:extLst>
+            <a:ext uri="{FF2B5EF4-FFF2-40B4-BE49-F238E27FC236}">
+              <a16:creationId xmlns:a16="http://schemas.microsoft.com/office/drawing/2014/main" id="{1CD65512-A818-976B-9CA3-B8E8F2E14EF5}"/>
+            </a:ext>
+          </a:extLst>
+        </p:cNvPr>
+        <p:cNvGrpSpPr/>
+        <p:nvPr/>
+      </p:nvGrpSpPr>
+      <p:grpSpPr>
+        <a:xfrm>
+          <a:off x="0" y="0"/>
+          <a:ext cx="0" cy="0"/>
+          <a:chOff x="0" y="0"/>
+          <a:chExt cx="0" cy="0"/>
+        </a:xfrm>
+      </p:grpSpPr>
+      <p:sp>
+        <p:nvSpPr>
+          <p:cNvPr id="3" name="TextBox 2">
+            <a:extLst>
+              <a:ext uri="{FF2B5EF4-FFF2-40B4-BE49-F238E27FC236}">
+                <a16:creationId xmlns:a16="http://schemas.microsoft.com/office/drawing/2014/main" id="{3801F3CE-637C-3226-55AC-1C128F6FBBA3}"/>
+              </a:ext>
+            </a:extLst>
+          </p:cNvPr>
+          <p:cNvSpPr txBox="1"/>
+          <p:nvPr/>
+        </p:nvSpPr>
+        <p:spPr>
+          <a:xfrm>
+            <a:off x="217714" y="255046"/>
+            <a:ext cx="11756571" cy="355354"/>
+          </a:xfrm>
+          <a:prstGeom prst="rect">
+            <a:avLst/>
+          </a:prstGeom>
+          <a:noFill/>
+        </p:spPr>
+        <p:txBody>
+          <a:bodyPr wrap="square">
+            <a:spAutoFit/>
+          </a:bodyPr>
+          <a:lstStyle/>
+          <a:p>
+            <a:pPr>
+              <a:lnSpc>
+                <a:spcPct val="150000"/>
+              </a:lnSpc>
+              <a:buNone/>
+            </a:pPr>
+            <a:r>
+              <a:rPr lang="en-US" altLang="en-US" sz="1300" b="1">
+                <a:latin typeface="Arial" panose="020B0604020202020204" pitchFamily="34" charset="0"/>
+              </a:rPr>
+              <a:t>SubCategory </a:t>
+            </a:r>
+            <a:r>
+              <a:rPr lang="az-Latn-AZ" altLang="en-US" sz="1300">
+                <a:latin typeface="Arial" panose="020B0604020202020204" pitchFamily="34" charset="0"/>
+              </a:rPr>
+              <a:t>üçün </a:t>
+            </a:r>
+            <a:r>
+              <a:rPr lang="en-US" altLang="en-US" sz="1300" b="1">
+                <a:latin typeface="Arial" panose="020B0604020202020204" pitchFamily="34" charset="0"/>
+              </a:rPr>
+              <a:t>datatable </a:t>
+            </a:r>
+            <a:r>
+              <a:rPr lang="az-Latn-AZ" altLang="en-US" sz="1300">
+                <a:latin typeface="Arial" panose="020B0604020202020204" pitchFamily="34" charset="0"/>
+              </a:rPr>
+              <a:t>yaradırıq.</a:t>
+            </a:r>
+            <a:endParaRPr lang="en-US" altLang="en-US" sz="1300">
+              <a:latin typeface="Arial" panose="020B0604020202020204" pitchFamily="34" charset="0"/>
+            </a:endParaRPr>
+          </a:p>
+        </p:txBody>
+      </p:sp>
+      <p:pic>
+        <p:nvPicPr>
+          <p:cNvPr id="4" name="Picture 3">
+            <a:extLst>
+              <a:ext uri="{FF2B5EF4-FFF2-40B4-BE49-F238E27FC236}">
+                <a16:creationId xmlns:a16="http://schemas.microsoft.com/office/drawing/2014/main" id="{80FC053C-B8B8-F93B-BD47-B7DB59E9D8C4}"/>
+              </a:ext>
+            </a:extLst>
+          </p:cNvPr>
+          <p:cNvPicPr>
+            <a:picLocks noChangeAspect="1"/>
+          </p:cNvPicPr>
+          <p:nvPr/>
+        </p:nvPicPr>
+        <p:blipFill>
+          <a:blip r:embed="rId2"/>
+          <a:stretch>
+            <a:fillRect/>
+          </a:stretch>
+        </p:blipFill>
+        <p:spPr>
+          <a:xfrm>
+            <a:off x="0" y="5267103"/>
+            <a:ext cx="8087854" cy="1590897"/>
+          </a:xfrm>
+          <a:prstGeom prst="rect">
+            <a:avLst/>
+          </a:prstGeom>
+        </p:spPr>
+      </p:pic>
+    </p:spTree>
+    <p:extLst>
+      <p:ext uri="{BB962C8B-B14F-4D97-AF65-F5344CB8AC3E}">
+        <p14:creationId xmlns:p14="http://schemas.microsoft.com/office/powerpoint/2010/main" val="160451441"/>
+      </p:ext>
+    </p:extLst>
+  </p:cSld>
+  <p:clrMapOvr>
+    <a:masterClrMapping/>
+  </p:clrMapOvr>
+</p:sld>
+</file>
+
+<file path=ppt/slides/slide3.xml><?xml version="1.0" encoding="utf-8"?>
+<p:sld xmlns:a="http://schemas.openxmlformats.org/drawingml/2006/main" xmlns:r="http://schemas.openxmlformats.org/officeDocument/2006/relationships" xmlns:p="http://schemas.openxmlformats.org/presentationml/2006/main">
+  <p:cSld>
+    <p:spTree>
+      <p:nvGrpSpPr>
+        <p:cNvPr id="1" name="">
+          <a:extLst>
+            <a:ext uri="{FF2B5EF4-FFF2-40B4-BE49-F238E27FC236}">
+              <a16:creationId xmlns:a16="http://schemas.microsoft.com/office/drawing/2014/main" id="{9D72A1E8-6475-B8D9-A21D-D0AB2972BBA8}"/>
+            </a:ext>
+          </a:extLst>
+        </p:cNvPr>
+        <p:cNvGrpSpPr/>
+        <p:nvPr/>
+      </p:nvGrpSpPr>
+      <p:grpSpPr>
+        <a:xfrm>
+          <a:off x="0" y="0"/>
+          <a:ext cx="0" cy="0"/>
+          <a:chOff x="0" y="0"/>
+          <a:chExt cx="0" cy="0"/>
+        </a:xfrm>
+      </p:grpSpPr>
+      <p:sp>
+        <p:nvSpPr>
+          <p:cNvPr id="3" name="TextBox 2">
+            <a:extLst>
+              <a:ext uri="{FF2B5EF4-FFF2-40B4-BE49-F238E27FC236}">
+                <a16:creationId xmlns:a16="http://schemas.microsoft.com/office/drawing/2014/main" id="{7E3464CB-02D3-4E5D-9BA3-26E9BD420D1D}"/>
+              </a:ext>
+            </a:extLst>
+          </p:cNvPr>
+          <p:cNvSpPr txBox="1"/>
+          <p:nvPr/>
+        </p:nvSpPr>
+        <p:spPr>
+          <a:xfrm>
+            <a:off x="217714" y="255046"/>
+            <a:ext cx="11756571" cy="355354"/>
+          </a:xfrm>
+          <a:prstGeom prst="rect">
+            <a:avLst/>
+          </a:prstGeom>
+          <a:noFill/>
+        </p:spPr>
+        <p:txBody>
+          <a:bodyPr wrap="square">
+            <a:spAutoFit/>
+          </a:bodyPr>
+          <a:lstStyle/>
+          <a:p>
+            <a:pPr>
+              <a:lnSpc>
+                <a:spcPct val="150000"/>
+              </a:lnSpc>
+              <a:buNone/>
+            </a:pPr>
+            <a:r>
+              <a:rPr kumimoji="0" lang="az-Latn-AZ" altLang="en-US" sz="1300" b="1" i="0" u="none" strike="noStrike" cap="none" normalizeH="0" baseline="0">
+                <a:ln>
+                  <a:noFill/>
+                </a:ln>
+                <a:solidFill>
+                  <a:schemeClr val="tx1"/>
+                </a:solidFill>
+                <a:effectLst/>
+                <a:latin typeface="Arial" panose="020B0604020202020204" pitchFamily="34" charset="0"/>
+              </a:rPr>
+              <a:t>Category</a:t>
+            </a:r>
+            <a:r>
+              <a:rPr kumimoji="0" lang="az-Latn-AZ" altLang="en-US" sz="1300" b="0" i="0" u="none" strike="noStrike" cap="none" normalizeH="0" baseline="0">
+                <a:ln>
+                  <a:noFill/>
+                </a:ln>
+                <a:solidFill>
+                  <a:schemeClr val="tx1"/>
+                </a:solidFill>
+                <a:effectLst/>
+                <a:latin typeface="Arial" panose="020B0604020202020204" pitchFamily="34" charset="0"/>
+              </a:rPr>
+              <a:t> </a:t>
+            </a:r>
+            <a:r>
+              <a:rPr lang="az-Latn-AZ" altLang="en-US" sz="1300">
+                <a:latin typeface="Arial" panose="020B0604020202020204" pitchFamily="34" charset="0"/>
+              </a:rPr>
+              <a:t>-də istifadə edilən şablonları, </a:t>
+            </a:r>
+            <a:r>
+              <a:rPr lang="az-Latn-AZ" altLang="en-US" sz="1300" b="1">
+                <a:latin typeface="Arial" panose="020B0604020202020204" pitchFamily="34" charset="0"/>
+              </a:rPr>
+              <a:t>SubCategory</a:t>
+            </a:r>
+            <a:r>
+              <a:rPr lang="az-Latn-AZ" altLang="en-US" sz="1300">
+                <a:latin typeface="Arial" panose="020B0604020202020204" pitchFamily="34" charset="0"/>
+              </a:rPr>
+              <a:t> adında qovluq yaradaraq bu qovluğa kopyalayırıq. </a:t>
+            </a:r>
+            <a:endParaRPr kumimoji="0" lang="en-US" altLang="en-US" sz="1300" b="0" i="0" u="none" strike="noStrike" cap="none" normalizeH="0" baseline="0">
+              <a:ln>
+                <a:noFill/>
+              </a:ln>
+              <a:solidFill>
+                <a:schemeClr val="tx1"/>
+              </a:solidFill>
+              <a:effectLst/>
+              <a:latin typeface="Arial" panose="020B0604020202020204" pitchFamily="34" charset="0"/>
+            </a:endParaRPr>
+          </a:p>
+        </p:txBody>
+      </p:sp>
+      <p:pic>
+        <p:nvPicPr>
+          <p:cNvPr id="4" name="Picture 3">
+            <a:extLst>
+              <a:ext uri="{FF2B5EF4-FFF2-40B4-BE49-F238E27FC236}">
+                <a16:creationId xmlns:a16="http://schemas.microsoft.com/office/drawing/2014/main" id="{544F81BF-9E7B-3CC6-07A4-87DF186FC17A}"/>
+              </a:ext>
+            </a:extLst>
+          </p:cNvPr>
+          <p:cNvPicPr>
+            <a:picLocks noChangeAspect="1"/>
+          </p:cNvPicPr>
+          <p:nvPr/>
+        </p:nvPicPr>
+        <p:blipFill>
+          <a:blip r:embed="rId2"/>
+          <a:stretch>
+            <a:fillRect/>
+          </a:stretch>
+        </p:blipFill>
+        <p:spPr>
+          <a:xfrm>
+            <a:off x="10358954" y="0"/>
+            <a:ext cx="1833046" cy="6858000"/>
+          </a:xfrm>
+          <a:prstGeom prst="rect">
+            <a:avLst/>
+          </a:prstGeom>
+        </p:spPr>
+      </p:pic>
+    </p:spTree>
+    <p:extLst>
+      <p:ext uri="{BB962C8B-B14F-4D97-AF65-F5344CB8AC3E}">
+        <p14:creationId xmlns:p14="http://schemas.microsoft.com/office/powerpoint/2010/main" val="236076515"/>
+      </p:ext>
+    </p:extLst>
+  </p:cSld>
+  <p:clrMapOvr>
+    <a:masterClrMapping/>
+  </p:clrMapOvr>
+</p:sld>
+</file>
+
+<file path=ppt/slides/slide4.xml><?xml version="1.0" encoding="utf-8"?>
 <p:sld xmlns:a="http://schemas.openxmlformats.org/drawingml/2006/main" xmlns:r="http://schemas.openxmlformats.org/officeDocument/2006/relationships" xmlns:p="http://schemas.openxmlformats.org/presentationml/2006/main">
   <p:cSld>
     <p:spTree>
@@ -3435,7 +4012,7 @@
         <p:spPr>
           <a:xfrm>
             <a:off x="217714" y="255046"/>
-            <a:ext cx="11756571" cy="355354"/>
+            <a:ext cx="5878285" cy="889154"/>
           </a:xfrm>
           <a:prstGeom prst="rect">
             <a:avLst/>
@@ -3455,21 +4032,117 @@
               <a:buNone/>
             </a:pPr>
             <a:r>
-              <a:rPr kumimoji="0" lang="en-US" altLang="en-US" sz="1300" b="0" i="0" u="none" strike="noStrike" cap="none" normalizeH="0" baseline="0">
-                <a:ln>
-                  <a:noFill/>
-                </a:ln>
+              <a:rPr lang="en-US" altLang="en-US" sz="1200" b="1">
                 <a:solidFill>
-                  <a:schemeClr val="tx1"/>
+                  <a:srgbClr val="00B050"/>
                 </a:solidFill>
-                <a:effectLst/>
-                <a:latin typeface="Arial" panose="020B0604020202020204" pitchFamily="34" charset="0"/>
-              </a:rPr>
-              <a:t>.</a:t>
-            </a:r>
-          </a:p>
-        </p:txBody>
-      </p:sp>
+                <a:latin typeface="Arial" panose="020B0604020202020204" pitchFamily="34" charset="0"/>
+              </a:rPr>
+              <a:t>database\migrations\2025_08_20_033135_create_sub_categories_table.php </a:t>
+            </a:r>
+            <a:r>
+              <a:rPr lang="az-Latn-AZ" altLang="en-US" sz="1200">
+                <a:latin typeface="Arial" panose="020B0604020202020204" pitchFamily="34" charset="0"/>
+              </a:rPr>
+              <a:t>cədvəlində göstəriləcək sütun adlarını təyin edirik və terminalda </a:t>
+            </a:r>
+            <a:r>
+              <a:rPr lang="az-Latn-AZ" altLang="en-US" sz="1200" b="1">
+                <a:latin typeface="Arial" panose="020B0604020202020204" pitchFamily="34" charset="0"/>
+              </a:rPr>
+              <a:t>migrate</a:t>
+            </a:r>
+            <a:r>
+              <a:rPr lang="az-Latn-AZ" altLang="en-US" sz="1200">
+                <a:latin typeface="Arial" panose="020B0604020202020204" pitchFamily="34" charset="0"/>
+              </a:rPr>
+              <a:t> əmri ilə </a:t>
+            </a:r>
+            <a:r>
+              <a:rPr lang="az-Latn-AZ" altLang="en-US" sz="1200" b="1">
+                <a:latin typeface="Arial" panose="020B0604020202020204" pitchFamily="34" charset="0"/>
+              </a:rPr>
+              <a:t>sub_categories </a:t>
+            </a:r>
+            <a:r>
+              <a:rPr lang="az-Latn-AZ" altLang="en-US" sz="1200">
+                <a:latin typeface="Arial" panose="020B0604020202020204" pitchFamily="34" charset="0"/>
+              </a:rPr>
+              <a:t>cədvəlini, verilənlər bazasına yerləşdiririk.</a:t>
+            </a:r>
+            <a:endParaRPr kumimoji="0" lang="en-US" altLang="en-US" sz="1200" b="0" i="0" u="none" strike="noStrike" cap="none" normalizeH="0" baseline="0">
+              <a:ln>
+                <a:noFill/>
+              </a:ln>
+              <a:solidFill>
+                <a:schemeClr val="tx1"/>
+              </a:solidFill>
+              <a:effectLst/>
+              <a:latin typeface="Arial" panose="020B0604020202020204" pitchFamily="34" charset="0"/>
+            </a:endParaRPr>
+          </a:p>
+        </p:txBody>
+      </p:sp>
+      <p:pic>
+        <p:nvPicPr>
+          <p:cNvPr id="6" name="Picture 5">
+            <a:extLst>
+              <a:ext uri="{FF2B5EF4-FFF2-40B4-BE49-F238E27FC236}">
+                <a16:creationId xmlns:a16="http://schemas.microsoft.com/office/drawing/2014/main" id="{7523EF7A-B7C6-4262-64FA-91B1DAD0145D}"/>
+              </a:ext>
+            </a:extLst>
+          </p:cNvPr>
+          <p:cNvPicPr>
+            <a:picLocks noChangeAspect="1"/>
+          </p:cNvPicPr>
+          <p:nvPr/>
+        </p:nvPicPr>
+        <p:blipFill>
+          <a:blip r:embed="rId2"/>
+          <a:stretch>
+            <a:fillRect/>
+          </a:stretch>
+        </p:blipFill>
+        <p:spPr>
+          <a:xfrm>
+            <a:off x="0" y="1507801"/>
+            <a:ext cx="5421803" cy="889155"/>
+          </a:xfrm>
+          <a:prstGeom prst="rect">
+            <a:avLst/>
+          </a:prstGeom>
+        </p:spPr>
+      </p:pic>
+      <p:pic>
+        <p:nvPicPr>
+          <p:cNvPr id="8" name="Picture 7">
+            <a:extLst>
+              <a:ext uri="{FF2B5EF4-FFF2-40B4-BE49-F238E27FC236}">
+                <a16:creationId xmlns:a16="http://schemas.microsoft.com/office/drawing/2014/main" id="{749B4453-CD16-2A07-B663-C1E0A550811D}"/>
+              </a:ext>
+            </a:extLst>
+          </p:cNvPr>
+          <p:cNvPicPr>
+            <a:picLocks noChangeAspect="1"/>
+          </p:cNvPicPr>
+          <p:nvPr/>
+        </p:nvPicPr>
+        <p:blipFill>
+          <a:blip r:embed="rId3"/>
+          <a:stretch>
+            <a:fillRect/>
+          </a:stretch>
+        </p:blipFill>
+        <p:spPr>
+          <a:xfrm>
+            <a:off x="6221950" y="0"/>
+            <a:ext cx="5970050" cy="6858000"/>
+          </a:xfrm>
+          <a:prstGeom prst="rect">
+            <a:avLst/>
+          </a:prstGeom>
+        </p:spPr>
+      </p:pic>
     </p:spTree>
     <p:extLst>
       <p:ext uri="{BB962C8B-B14F-4D97-AF65-F5344CB8AC3E}">
@@ -3483,7 +4156,7 @@
 </p:sld>
 </file>
 
-<file path=ppt/slides/slide3.xml><?xml version="1.0" encoding="utf-8"?>
+<file path=ppt/slides/slide5.xml><?xml version="1.0" encoding="utf-8"?>
 <p:sld xmlns:a="http://schemas.openxmlformats.org/drawingml/2006/main" xmlns:r="http://schemas.openxmlformats.org/officeDocument/2006/relationships" xmlns:p="http://schemas.openxmlformats.org/presentationml/2006/main">
   <p:cSld>
     <p:spTree>
@@ -3491,7 +4164,7 @@
         <p:cNvPr id="1" name="">
           <a:extLst>
             <a:ext uri="{FF2B5EF4-FFF2-40B4-BE49-F238E27FC236}">
-              <a16:creationId xmlns:a16="http://schemas.microsoft.com/office/drawing/2014/main" id="{ECE25D7D-A080-F22B-7E8D-36EC827289A1}"/>
+              <a16:creationId xmlns:a16="http://schemas.microsoft.com/office/drawing/2014/main" id="{A2378D7D-CEAE-3C13-9C8C-9626CEF8C780}"/>
             </a:ext>
           </a:extLst>
         </p:cNvPr>
@@ -3511,7 +4184,7 @@
           <p:cNvPr id="3" name="TextBox 2">
             <a:extLst>
               <a:ext uri="{FF2B5EF4-FFF2-40B4-BE49-F238E27FC236}">
-                <a16:creationId xmlns:a16="http://schemas.microsoft.com/office/drawing/2014/main" id="{E33F16A3-A6E8-401E-847B-09570DC6E4CB}"/>
+                <a16:creationId xmlns:a16="http://schemas.microsoft.com/office/drawing/2014/main" id="{E619C4AF-5287-AC68-5B6D-6C08E367BB4A}"/>
               </a:ext>
             </a:extLst>
           </p:cNvPr>
@@ -3541,25 +4214,725 @@
               <a:buNone/>
             </a:pPr>
             <a:r>
-              <a:rPr kumimoji="0" lang="en-US" altLang="en-US" sz="1300" b="0" i="0" u="none" strike="noStrike" cap="none" normalizeH="0" baseline="0">
-                <a:ln>
-                  <a:noFill/>
-                </a:ln>
-                <a:solidFill>
-                  <a:schemeClr val="tx1"/>
-                </a:solidFill>
-                <a:effectLst/>
-                <a:latin typeface="Arial" panose="020B0604020202020204" pitchFamily="34" charset="0"/>
-              </a:rPr>
-              <a:t>.</a:t>
-            </a:r>
-          </a:p>
-        </p:txBody>
-      </p:sp>
+              <a:rPr lang="en-US" altLang="en-US" sz="1300" b="1">
+                <a:latin typeface="Arial" panose="020B0604020202020204" pitchFamily="34" charset="0"/>
+              </a:rPr>
+              <a:t>routes\admin.php</a:t>
+            </a:r>
+            <a:r>
+              <a:rPr lang="az-Latn-AZ" altLang="en-US" sz="1300" b="1">
+                <a:latin typeface="Arial" panose="020B0604020202020204" pitchFamily="34" charset="0"/>
+              </a:rPr>
+              <a:t> </a:t>
+            </a:r>
+            <a:r>
+              <a:rPr lang="az-Latn-AZ" altLang="en-US" sz="1300">
+                <a:latin typeface="Arial" panose="020B0604020202020204" pitchFamily="34" charset="0"/>
+              </a:rPr>
+              <a:t>-də, </a:t>
+            </a:r>
+            <a:r>
+              <a:rPr lang="az-Latn-AZ" altLang="en-US" sz="1300" b="1">
+                <a:latin typeface="Arial" panose="020B0604020202020204" pitchFamily="34" charset="0"/>
+              </a:rPr>
+              <a:t>SubCategory</a:t>
+            </a:r>
+            <a:r>
+              <a:rPr lang="az-Latn-AZ" altLang="en-US" sz="1300">
+                <a:latin typeface="Arial" panose="020B0604020202020204" pitchFamily="34" charset="0"/>
+              </a:rPr>
+              <a:t> üçün </a:t>
+            </a:r>
+            <a:r>
+              <a:rPr lang="az-Latn-AZ" altLang="en-US" sz="1300" b="1">
+                <a:latin typeface="Arial" panose="020B0604020202020204" pitchFamily="34" charset="0"/>
+              </a:rPr>
+              <a:t>route</a:t>
+            </a:r>
+            <a:r>
+              <a:rPr lang="az-Latn-AZ" altLang="en-US" sz="1300">
+                <a:latin typeface="Arial" panose="020B0604020202020204" pitchFamily="34" charset="0"/>
+              </a:rPr>
+              <a:t> -lar əlavə edirik.</a:t>
+            </a:r>
+            <a:endParaRPr kumimoji="0" lang="en-US" altLang="en-US" sz="1300" b="0" i="0" u="none" strike="noStrike" cap="none" normalizeH="0" baseline="0">
+              <a:ln>
+                <a:noFill/>
+              </a:ln>
+              <a:solidFill>
+                <a:schemeClr val="tx1"/>
+              </a:solidFill>
+              <a:effectLst/>
+              <a:latin typeface="Arial" panose="020B0604020202020204" pitchFamily="34" charset="0"/>
+            </a:endParaRPr>
+          </a:p>
+        </p:txBody>
+      </p:sp>
+      <p:pic>
+        <p:nvPicPr>
+          <p:cNvPr id="4" name="Picture 3">
+            <a:extLst>
+              <a:ext uri="{FF2B5EF4-FFF2-40B4-BE49-F238E27FC236}">
+                <a16:creationId xmlns:a16="http://schemas.microsoft.com/office/drawing/2014/main" id="{B19C5AAE-8504-592D-248F-976A1698FD79}"/>
+              </a:ext>
+            </a:extLst>
+          </p:cNvPr>
+          <p:cNvPicPr>
+            <a:picLocks noChangeAspect="1"/>
+          </p:cNvPicPr>
+          <p:nvPr/>
+        </p:nvPicPr>
+        <p:blipFill>
+          <a:blip r:embed="rId2"/>
+          <a:stretch>
+            <a:fillRect/>
+          </a:stretch>
+        </p:blipFill>
+        <p:spPr>
+          <a:xfrm>
+            <a:off x="3103418" y="929598"/>
+            <a:ext cx="9088582" cy="5928401"/>
+          </a:xfrm>
+          <a:prstGeom prst="rect">
+            <a:avLst/>
+          </a:prstGeom>
+        </p:spPr>
+      </p:pic>
     </p:spTree>
     <p:extLst>
       <p:ext uri="{BB962C8B-B14F-4D97-AF65-F5344CB8AC3E}">
-        <p14:creationId xmlns:p14="http://schemas.microsoft.com/office/powerpoint/2010/main" val="3095838342"/>
+        <p14:creationId xmlns:p14="http://schemas.microsoft.com/office/powerpoint/2010/main" val="3479164893"/>
+      </p:ext>
+    </p:extLst>
+  </p:cSld>
+  <p:clrMapOvr>
+    <a:masterClrMapping/>
+  </p:clrMapOvr>
+</p:sld>
+</file>
+
+<file path=ppt/slides/slide6.xml><?xml version="1.0" encoding="utf-8"?>
+<p:sld xmlns:a="http://schemas.openxmlformats.org/drawingml/2006/main" xmlns:r="http://schemas.openxmlformats.org/officeDocument/2006/relationships" xmlns:p="http://schemas.openxmlformats.org/presentationml/2006/main">
+  <p:cSld>
+    <p:spTree>
+      <p:nvGrpSpPr>
+        <p:cNvPr id="1" name="">
+          <a:extLst>
+            <a:ext uri="{FF2B5EF4-FFF2-40B4-BE49-F238E27FC236}">
+              <a16:creationId xmlns:a16="http://schemas.microsoft.com/office/drawing/2014/main" id="{7581706D-94FB-A76E-6398-1C40353ECD86}"/>
+            </a:ext>
+          </a:extLst>
+        </p:cNvPr>
+        <p:cNvGrpSpPr/>
+        <p:nvPr/>
+      </p:nvGrpSpPr>
+      <p:grpSpPr>
+        <a:xfrm>
+          <a:off x="0" y="0"/>
+          <a:ext cx="0" cy="0"/>
+          <a:chOff x="0" y="0"/>
+          <a:chExt cx="0" cy="0"/>
+        </a:xfrm>
+      </p:grpSpPr>
+      <p:sp>
+        <p:nvSpPr>
+          <p:cNvPr id="3" name="TextBox 2">
+            <a:extLst>
+              <a:ext uri="{FF2B5EF4-FFF2-40B4-BE49-F238E27FC236}">
+                <a16:creationId xmlns:a16="http://schemas.microsoft.com/office/drawing/2014/main" id="{465ECEA7-F38C-A47E-7F0E-273F9DAB73C9}"/>
+              </a:ext>
+            </a:extLst>
+          </p:cNvPr>
+          <p:cNvSpPr txBox="1"/>
+          <p:nvPr/>
+        </p:nvSpPr>
+        <p:spPr>
+          <a:xfrm>
+            <a:off x="217714" y="255046"/>
+            <a:ext cx="11756571" cy="655436"/>
+          </a:xfrm>
+          <a:prstGeom prst="rect">
+            <a:avLst/>
+          </a:prstGeom>
+          <a:noFill/>
+        </p:spPr>
+        <p:txBody>
+          <a:bodyPr wrap="square">
+            <a:spAutoFit/>
+          </a:bodyPr>
+          <a:lstStyle/>
+          <a:p>
+            <a:pPr>
+              <a:lnSpc>
+                <a:spcPct val="150000"/>
+              </a:lnSpc>
+              <a:buNone/>
+            </a:pPr>
+            <a:r>
+              <a:rPr lang="az-Latn-AZ" altLang="en-US" sz="1300">
+                <a:latin typeface="Arial" panose="020B0604020202020204" pitchFamily="34" charset="0"/>
+              </a:rPr>
+              <a:t>`</a:t>
+            </a:r>
+            <a:r>
+              <a:rPr lang="en-US" altLang="en-US" sz="1300" b="1">
+                <a:latin typeface="Arial" panose="020B0604020202020204" pitchFamily="34" charset="0"/>
+              </a:rPr>
+              <a:t>resources\views\admin\sub-category\</a:t>
+            </a:r>
+            <a:r>
+              <a:rPr lang="en-US" altLang="en-US" sz="1300" b="1" u="sng">
+                <a:latin typeface="Arial" panose="020B0604020202020204" pitchFamily="34" charset="0"/>
+              </a:rPr>
+              <a:t>index.blade.php</a:t>
+            </a:r>
+            <a:r>
+              <a:rPr lang="az-Latn-AZ" altLang="en-US" sz="1300">
+                <a:latin typeface="Arial" panose="020B0604020202020204" pitchFamily="34" charset="0"/>
+              </a:rPr>
+              <a:t>` şablonunu çağırmaq üçün, `</a:t>
+            </a:r>
+            <a:r>
+              <a:rPr lang="en-US" altLang="en-US" sz="1300" b="1">
+                <a:latin typeface="Arial" panose="020B0604020202020204" pitchFamily="34" charset="0"/>
+              </a:rPr>
+              <a:t>resources\views\admin\layouts\</a:t>
+            </a:r>
+            <a:r>
+              <a:rPr lang="en-US" altLang="en-US" sz="1300" b="1" u="sng">
+                <a:latin typeface="Arial" panose="020B0604020202020204" pitchFamily="34" charset="0"/>
+              </a:rPr>
+              <a:t>sidebar.blade.php</a:t>
+            </a:r>
+            <a:r>
+              <a:rPr lang="az-Latn-AZ" altLang="en-US" sz="1300">
+                <a:latin typeface="Arial" panose="020B0604020202020204" pitchFamily="34" charset="0"/>
+              </a:rPr>
+              <a:t>` faylında olan </a:t>
+            </a:r>
+            <a:r>
+              <a:rPr lang="en-US" altLang="en-US" sz="1300" b="1">
+                <a:latin typeface="Arial" panose="020B0604020202020204" pitchFamily="34" charset="0"/>
+              </a:rPr>
+              <a:t>&lt;a&gt; </a:t>
+            </a:r>
+            <a:r>
+              <a:rPr lang="az-Latn-AZ" altLang="en-US" sz="1300">
+                <a:latin typeface="Arial" panose="020B0604020202020204" pitchFamily="34" charset="0"/>
+              </a:rPr>
+              <a:t>elementinə `</a:t>
+            </a:r>
+            <a:r>
+              <a:rPr lang="az-Latn-AZ" altLang="en-US" sz="1300" b="1">
+                <a:solidFill>
+                  <a:srgbClr val="00B050"/>
+                </a:solidFill>
+                <a:latin typeface="Arial" panose="020B0604020202020204" pitchFamily="34" charset="0"/>
+              </a:rPr>
+              <a:t>route('admin.sub-category.index’)</a:t>
+            </a:r>
+            <a:r>
+              <a:rPr lang="az-Latn-AZ" altLang="en-US" sz="1300">
+                <a:latin typeface="Arial" panose="020B0604020202020204" pitchFamily="34" charset="0"/>
+              </a:rPr>
+              <a:t>` adlı routu əlavə edirik.</a:t>
+            </a:r>
+            <a:endParaRPr kumimoji="0" lang="en-US" altLang="en-US" sz="1300" b="0" i="0" u="none" strike="noStrike" cap="none" normalizeH="0" baseline="0">
+              <a:ln>
+                <a:noFill/>
+              </a:ln>
+              <a:solidFill>
+                <a:schemeClr val="tx1"/>
+              </a:solidFill>
+              <a:effectLst/>
+              <a:latin typeface="Arial" panose="020B0604020202020204" pitchFamily="34" charset="0"/>
+            </a:endParaRPr>
+          </a:p>
+        </p:txBody>
+      </p:sp>
+      <p:pic>
+        <p:nvPicPr>
+          <p:cNvPr id="4" name="Picture 3">
+            <a:extLst>
+              <a:ext uri="{FF2B5EF4-FFF2-40B4-BE49-F238E27FC236}">
+                <a16:creationId xmlns:a16="http://schemas.microsoft.com/office/drawing/2014/main" id="{264B3241-8681-A70F-1BEB-EA987C35FAA0}"/>
+              </a:ext>
+            </a:extLst>
+          </p:cNvPr>
+          <p:cNvPicPr>
+            <a:picLocks noChangeAspect="1"/>
+          </p:cNvPicPr>
+          <p:nvPr/>
+        </p:nvPicPr>
+        <p:blipFill>
+          <a:blip r:embed="rId2"/>
+          <a:stretch>
+            <a:fillRect/>
+          </a:stretch>
+        </p:blipFill>
+        <p:spPr>
+          <a:xfrm>
+            <a:off x="2795706" y="1671782"/>
+            <a:ext cx="9396294" cy="5186218"/>
+          </a:xfrm>
+          <a:prstGeom prst="rect">
+            <a:avLst/>
+          </a:prstGeom>
+        </p:spPr>
+      </p:pic>
+    </p:spTree>
+    <p:extLst>
+      <p:ext uri="{BB962C8B-B14F-4D97-AF65-F5344CB8AC3E}">
+        <p14:creationId xmlns:p14="http://schemas.microsoft.com/office/powerpoint/2010/main" val="17421336"/>
+      </p:ext>
+    </p:extLst>
+  </p:cSld>
+  <p:clrMapOvr>
+    <a:masterClrMapping/>
+  </p:clrMapOvr>
+</p:sld>
+</file>
+
+<file path=ppt/slides/slide7.xml><?xml version="1.0" encoding="utf-8"?>
+<p:sld xmlns:a="http://schemas.openxmlformats.org/drawingml/2006/main" xmlns:r="http://schemas.openxmlformats.org/officeDocument/2006/relationships" xmlns:p="http://schemas.openxmlformats.org/presentationml/2006/main">
+  <p:cSld>
+    <p:spTree>
+      <p:nvGrpSpPr>
+        <p:cNvPr id="1" name="">
+          <a:extLst>
+            <a:ext uri="{FF2B5EF4-FFF2-40B4-BE49-F238E27FC236}">
+              <a16:creationId xmlns:a16="http://schemas.microsoft.com/office/drawing/2014/main" id="{55A24C03-D92D-E179-AD4D-B45532EEB529}"/>
+            </a:ext>
+          </a:extLst>
+        </p:cNvPr>
+        <p:cNvGrpSpPr/>
+        <p:nvPr/>
+      </p:nvGrpSpPr>
+      <p:grpSpPr>
+        <a:xfrm>
+          <a:off x="0" y="0"/>
+          <a:ext cx="0" cy="0"/>
+          <a:chOff x="0" y="0"/>
+          <a:chExt cx="0" cy="0"/>
+        </a:xfrm>
+      </p:grpSpPr>
+      <p:sp>
+        <p:nvSpPr>
+          <p:cNvPr id="3" name="TextBox 2">
+            <a:extLst>
+              <a:ext uri="{FF2B5EF4-FFF2-40B4-BE49-F238E27FC236}">
+                <a16:creationId xmlns:a16="http://schemas.microsoft.com/office/drawing/2014/main" id="{37B4E3DA-E9B9-2650-BBC2-51A82BE95400}"/>
+              </a:ext>
+            </a:extLst>
+          </p:cNvPr>
+          <p:cNvSpPr txBox="1"/>
+          <p:nvPr/>
+        </p:nvSpPr>
+        <p:spPr>
+          <a:xfrm>
+            <a:off x="0" y="190392"/>
+            <a:ext cx="8209708" cy="655436"/>
+          </a:xfrm>
+          <a:prstGeom prst="rect">
+            <a:avLst/>
+          </a:prstGeom>
+          <a:noFill/>
+        </p:spPr>
+        <p:txBody>
+          <a:bodyPr wrap="square">
+            <a:spAutoFit/>
+          </a:bodyPr>
+          <a:lstStyle/>
+          <a:p>
+            <a:pPr>
+              <a:lnSpc>
+                <a:spcPct val="150000"/>
+              </a:lnSpc>
+              <a:buNone/>
+            </a:pPr>
+            <a:r>
+              <a:rPr lang="en-US" altLang="en-US" sz="1300" b="1">
+                <a:latin typeface="Arial" panose="020B0604020202020204" pitchFamily="34" charset="0"/>
+              </a:rPr>
+              <a:t>&lt;a&gt; </a:t>
+            </a:r>
+            <a:r>
+              <a:rPr lang="az-Latn-AZ" altLang="en-US" sz="1300">
+                <a:latin typeface="Arial" panose="020B0604020202020204" pitchFamily="34" charset="0"/>
+              </a:rPr>
+              <a:t>elementinə klikləndikdə, həmin </a:t>
+            </a:r>
+            <a:r>
+              <a:rPr lang="az-Latn-AZ" altLang="en-US" sz="1300" b="1">
+                <a:solidFill>
+                  <a:srgbClr val="00B050"/>
+                </a:solidFill>
+                <a:latin typeface="Arial" panose="020B0604020202020204" pitchFamily="34" charset="0"/>
+              </a:rPr>
+              <a:t>route</a:t>
+            </a:r>
+            <a:r>
+              <a:rPr lang="az-Latn-AZ" altLang="en-US" sz="1300">
+                <a:latin typeface="Arial" panose="020B0604020202020204" pitchFamily="34" charset="0"/>
+              </a:rPr>
+              <a:t> `</a:t>
+            </a:r>
+            <a:r>
+              <a:rPr lang="az-Latn-AZ" altLang="en-US" sz="1300" b="1">
+                <a:latin typeface="Arial" panose="020B0604020202020204" pitchFamily="34" charset="0"/>
+              </a:rPr>
+              <a:t>app\Http\Controllers\Backend\</a:t>
+            </a:r>
+            <a:r>
+              <a:rPr lang="az-Latn-AZ" altLang="en-US" sz="1300" b="1" u="sng">
+                <a:latin typeface="Arial" panose="020B0604020202020204" pitchFamily="34" charset="0"/>
+              </a:rPr>
+              <a:t>SubCategoryController.php</a:t>
+            </a:r>
+            <a:r>
+              <a:rPr lang="az-Latn-AZ" altLang="en-US" sz="1300">
+                <a:latin typeface="Arial" panose="020B0604020202020204" pitchFamily="34" charset="0"/>
+              </a:rPr>
+              <a:t>` adlı kontrollerin </a:t>
+            </a:r>
+            <a:r>
+              <a:rPr lang="az-Latn-AZ" altLang="en-US" sz="1300" b="1">
+                <a:latin typeface="Arial" panose="020B0604020202020204" pitchFamily="34" charset="0"/>
+              </a:rPr>
+              <a:t>index() </a:t>
+            </a:r>
+            <a:r>
+              <a:rPr lang="az-Latn-AZ" altLang="en-US" sz="1300">
+                <a:latin typeface="Arial" panose="020B0604020202020204" pitchFamily="34" charset="0"/>
+              </a:rPr>
+              <a:t>metodunu işə salır və şablon yüklənir.</a:t>
+            </a:r>
+            <a:endParaRPr kumimoji="0" lang="en-US" altLang="en-US" sz="1300" b="0" i="0" u="none" strike="noStrike" cap="none" normalizeH="0" baseline="0">
+              <a:ln>
+                <a:noFill/>
+              </a:ln>
+              <a:solidFill>
+                <a:schemeClr val="tx1"/>
+              </a:solidFill>
+              <a:effectLst/>
+              <a:latin typeface="Arial" panose="020B0604020202020204" pitchFamily="34" charset="0"/>
+            </a:endParaRPr>
+          </a:p>
+        </p:txBody>
+      </p:sp>
+      <p:pic>
+        <p:nvPicPr>
+          <p:cNvPr id="4" name="Picture 3">
+            <a:extLst>
+              <a:ext uri="{FF2B5EF4-FFF2-40B4-BE49-F238E27FC236}">
+                <a16:creationId xmlns:a16="http://schemas.microsoft.com/office/drawing/2014/main" id="{3EB99749-8588-46F3-A3D4-A50F6EFB635A}"/>
+              </a:ext>
+            </a:extLst>
+          </p:cNvPr>
+          <p:cNvPicPr>
+            <a:picLocks noChangeAspect="1"/>
+          </p:cNvPicPr>
+          <p:nvPr/>
+        </p:nvPicPr>
+        <p:blipFill>
+          <a:blip r:embed="rId2"/>
+          <a:stretch>
+            <a:fillRect/>
+          </a:stretch>
+        </p:blipFill>
+        <p:spPr>
+          <a:xfrm>
+            <a:off x="8209708" y="0"/>
+            <a:ext cx="3982292" cy="6858000"/>
+          </a:xfrm>
+          <a:prstGeom prst="rect">
+            <a:avLst/>
+          </a:prstGeom>
+        </p:spPr>
+      </p:pic>
+    </p:spTree>
+    <p:extLst>
+      <p:ext uri="{BB962C8B-B14F-4D97-AF65-F5344CB8AC3E}">
+        <p14:creationId xmlns:p14="http://schemas.microsoft.com/office/powerpoint/2010/main" val="2688258280"/>
+      </p:ext>
+    </p:extLst>
+  </p:cSld>
+  <p:clrMapOvr>
+    <a:masterClrMapping/>
+  </p:clrMapOvr>
+</p:sld>
+</file>
+
+<file path=ppt/slides/slide8.xml><?xml version="1.0" encoding="utf-8"?>
+<p:sld xmlns:a="http://schemas.openxmlformats.org/drawingml/2006/main" xmlns:r="http://schemas.openxmlformats.org/officeDocument/2006/relationships" xmlns:p="http://schemas.openxmlformats.org/presentationml/2006/main">
+  <p:cSld>
+    <p:spTree>
+      <p:nvGrpSpPr>
+        <p:cNvPr id="1" name="">
+          <a:extLst>
+            <a:ext uri="{FF2B5EF4-FFF2-40B4-BE49-F238E27FC236}">
+              <a16:creationId xmlns:a16="http://schemas.microsoft.com/office/drawing/2014/main" id="{7043CFDF-A285-2084-D3BD-DB03612C9D5D}"/>
+            </a:ext>
+          </a:extLst>
+        </p:cNvPr>
+        <p:cNvGrpSpPr/>
+        <p:nvPr/>
+      </p:nvGrpSpPr>
+      <p:grpSpPr>
+        <a:xfrm>
+          <a:off x="0" y="0"/>
+          <a:ext cx="0" cy="0"/>
+          <a:chOff x="0" y="0"/>
+          <a:chExt cx="0" cy="0"/>
+        </a:xfrm>
+      </p:grpSpPr>
+      <p:sp>
+        <p:nvSpPr>
+          <p:cNvPr id="3" name="TextBox 2">
+            <a:extLst>
+              <a:ext uri="{FF2B5EF4-FFF2-40B4-BE49-F238E27FC236}">
+                <a16:creationId xmlns:a16="http://schemas.microsoft.com/office/drawing/2014/main" id="{A81CF118-625A-9C63-F534-D15AFD09F066}"/>
+              </a:ext>
+            </a:extLst>
+          </p:cNvPr>
+          <p:cNvSpPr txBox="1"/>
+          <p:nvPr/>
+        </p:nvSpPr>
+        <p:spPr>
+          <a:xfrm>
+            <a:off x="217714" y="255046"/>
+            <a:ext cx="11756571" cy="955518"/>
+          </a:xfrm>
+          <a:prstGeom prst="rect">
+            <a:avLst/>
+          </a:prstGeom>
+          <a:noFill/>
+        </p:spPr>
+        <p:txBody>
+          <a:bodyPr wrap="square">
+            <a:spAutoFit/>
+          </a:bodyPr>
+          <a:lstStyle/>
+          <a:p>
+            <a:pPr>
+              <a:lnSpc>
+                <a:spcPct val="150000"/>
+              </a:lnSpc>
+              <a:buNone/>
+            </a:pPr>
+            <a:r>
+              <a:rPr lang="az-Latn-AZ" altLang="en-US" sz="1300">
+                <a:latin typeface="Arial" panose="020B0604020202020204" pitchFamily="34" charset="0"/>
+              </a:rPr>
+              <a:t>`</a:t>
+            </a:r>
+            <a:r>
+              <a:rPr lang="en-US" altLang="en-US" sz="1300">
+                <a:latin typeface="Arial" panose="020B0604020202020204" pitchFamily="34" charset="0"/>
+              </a:rPr>
+              <a:t>resources\views\admin\sub-category\index.blade.php</a:t>
+            </a:r>
+            <a:r>
+              <a:rPr lang="az-Latn-AZ" altLang="en-US" sz="1300">
+                <a:latin typeface="Arial" panose="020B0604020202020204" pitchFamily="34" charset="0"/>
+              </a:rPr>
+              <a:t>` şablonunda, çox bir dəyişiklik etmirik. Sonra edəcəyik. </a:t>
+            </a:r>
+          </a:p>
+          <a:p>
+            <a:pPr>
+              <a:lnSpc>
+                <a:spcPct val="150000"/>
+              </a:lnSpc>
+              <a:buNone/>
+            </a:pPr>
+            <a:endParaRPr lang="az-Latn-AZ" altLang="en-US" sz="1300">
+              <a:latin typeface="Arial" panose="020B0604020202020204" pitchFamily="34" charset="0"/>
+            </a:endParaRPr>
+          </a:p>
+          <a:p>
+            <a:pPr>
+              <a:lnSpc>
+                <a:spcPct val="150000"/>
+              </a:lnSpc>
+              <a:buNone/>
+            </a:pPr>
+            <a:r>
+              <a:rPr lang="az-Latn-AZ" altLang="en-US" sz="1300">
+                <a:latin typeface="Arial" panose="020B0604020202020204" pitchFamily="34" charset="0"/>
+              </a:rPr>
+              <a:t>İndilik isə, qırmızı ilə işarətlənən yerləri dəyişdirdik.</a:t>
+            </a:r>
+          </a:p>
+        </p:txBody>
+      </p:sp>
+      <p:pic>
+        <p:nvPicPr>
+          <p:cNvPr id="4" name="Picture 3">
+            <a:extLst>
+              <a:ext uri="{FF2B5EF4-FFF2-40B4-BE49-F238E27FC236}">
+                <a16:creationId xmlns:a16="http://schemas.microsoft.com/office/drawing/2014/main" id="{FF0DC329-B87D-A4D9-6695-90D7217711A6}"/>
+              </a:ext>
+            </a:extLst>
+          </p:cNvPr>
+          <p:cNvPicPr>
+            <a:picLocks noChangeAspect="1"/>
+          </p:cNvPicPr>
+          <p:nvPr/>
+        </p:nvPicPr>
+        <p:blipFill>
+          <a:blip r:embed="rId2"/>
+          <a:stretch>
+            <a:fillRect/>
+          </a:stretch>
+        </p:blipFill>
+        <p:spPr>
+          <a:xfrm>
+            <a:off x="5527456" y="1414847"/>
+            <a:ext cx="6664544" cy="5443153"/>
+          </a:xfrm>
+          <a:prstGeom prst="rect">
+            <a:avLst/>
+          </a:prstGeom>
+        </p:spPr>
+      </p:pic>
+    </p:spTree>
+    <p:extLst>
+      <p:ext uri="{BB962C8B-B14F-4D97-AF65-F5344CB8AC3E}">
+        <p14:creationId xmlns:p14="http://schemas.microsoft.com/office/powerpoint/2010/main" val="1998521007"/>
+      </p:ext>
+    </p:extLst>
+  </p:cSld>
+  <p:clrMapOvr>
+    <a:masterClrMapping/>
+  </p:clrMapOvr>
+</p:sld>
+</file>
+
+<file path=ppt/slides/slide9.xml><?xml version="1.0" encoding="utf-8"?>
+<p:sld xmlns:a="http://schemas.openxmlformats.org/drawingml/2006/main" xmlns:r="http://schemas.openxmlformats.org/officeDocument/2006/relationships" xmlns:p="http://schemas.openxmlformats.org/presentationml/2006/main">
+  <p:cSld>
+    <p:spTree>
+      <p:nvGrpSpPr>
+        <p:cNvPr id="1" name="">
+          <a:extLst>
+            <a:ext uri="{FF2B5EF4-FFF2-40B4-BE49-F238E27FC236}">
+              <a16:creationId xmlns:a16="http://schemas.microsoft.com/office/drawing/2014/main" id="{B52D0D51-EAD9-C870-B036-E015C7710DA2}"/>
+            </a:ext>
+          </a:extLst>
+        </p:cNvPr>
+        <p:cNvGrpSpPr/>
+        <p:nvPr/>
+      </p:nvGrpSpPr>
+      <p:grpSpPr>
+        <a:xfrm>
+          <a:off x="0" y="0"/>
+          <a:ext cx="0" cy="0"/>
+          <a:chOff x="0" y="0"/>
+          <a:chExt cx="0" cy="0"/>
+        </a:xfrm>
+      </p:grpSpPr>
+      <p:sp>
+        <p:nvSpPr>
+          <p:cNvPr id="3" name="TextBox 2">
+            <a:extLst>
+              <a:ext uri="{FF2B5EF4-FFF2-40B4-BE49-F238E27FC236}">
+                <a16:creationId xmlns:a16="http://schemas.microsoft.com/office/drawing/2014/main" id="{A540E685-66F8-0E47-8676-EC7CA8C78285}"/>
+              </a:ext>
+            </a:extLst>
+          </p:cNvPr>
+          <p:cNvSpPr txBox="1"/>
+          <p:nvPr/>
+        </p:nvSpPr>
+        <p:spPr>
+          <a:xfrm>
+            <a:off x="217714" y="255046"/>
+            <a:ext cx="11756571" cy="355354"/>
+          </a:xfrm>
+          <a:prstGeom prst="rect">
+            <a:avLst/>
+          </a:prstGeom>
+          <a:noFill/>
+        </p:spPr>
+        <p:txBody>
+          <a:bodyPr wrap="square">
+            <a:spAutoFit/>
+          </a:bodyPr>
+          <a:lstStyle/>
+          <a:p>
+            <a:pPr>
+              <a:lnSpc>
+                <a:spcPct val="150000"/>
+              </a:lnSpc>
+              <a:buNone/>
+            </a:pPr>
+            <a:r>
+              <a:rPr lang="az-Latn-AZ" altLang="en-US" sz="1300">
+                <a:latin typeface="Arial" panose="020B0604020202020204" pitchFamily="34" charset="0"/>
+              </a:rPr>
+              <a:t>Nəticə.</a:t>
+            </a:r>
+            <a:endParaRPr kumimoji="0" lang="en-US" altLang="en-US" sz="1300" b="0" i="0" u="none" strike="noStrike" cap="none" normalizeH="0" baseline="0">
+              <a:ln>
+                <a:noFill/>
+              </a:ln>
+              <a:solidFill>
+                <a:schemeClr val="tx1"/>
+              </a:solidFill>
+              <a:effectLst/>
+              <a:latin typeface="Arial" panose="020B0604020202020204" pitchFamily="34" charset="0"/>
+            </a:endParaRPr>
+          </a:p>
+        </p:txBody>
+      </p:sp>
+      <p:pic>
+        <p:nvPicPr>
+          <p:cNvPr id="4" name="Picture 3">
+            <a:extLst>
+              <a:ext uri="{FF2B5EF4-FFF2-40B4-BE49-F238E27FC236}">
+                <a16:creationId xmlns:a16="http://schemas.microsoft.com/office/drawing/2014/main" id="{653C84E1-B0B8-5BC5-8F36-18D4D4F44C7B}"/>
+              </a:ext>
+            </a:extLst>
+          </p:cNvPr>
+          <p:cNvPicPr>
+            <a:picLocks noChangeAspect="1"/>
+          </p:cNvPicPr>
+          <p:nvPr/>
+        </p:nvPicPr>
+        <p:blipFill>
+          <a:blip r:embed="rId2"/>
+          <a:stretch>
+            <a:fillRect/>
+          </a:stretch>
+        </p:blipFill>
+        <p:spPr>
+          <a:xfrm>
+            <a:off x="0" y="1637743"/>
+            <a:ext cx="12192000" cy="3582513"/>
+          </a:xfrm>
+          <a:prstGeom prst="rect">
+            <a:avLst/>
+          </a:prstGeom>
+          <a:ln w="38100" cap="sq">
+            <a:solidFill>
+              <a:srgbClr val="000000"/>
+            </a:solidFill>
+            <a:prstDash val="solid"/>
+            <a:miter lim="800000"/>
+          </a:ln>
+          <a:effectLst>
+            <a:outerShdw blurRad="50800" dist="38100" dir="2700000" algn="tl" rotWithShape="0">
+              <a:srgbClr val="000000">
+                <a:alpha val="43000"/>
+              </a:srgbClr>
+            </a:outerShdw>
+          </a:effectLst>
+        </p:spPr>
+      </p:pic>
+    </p:spTree>
+    <p:extLst>
+      <p:ext uri="{BB962C8B-B14F-4D97-AF65-F5344CB8AC3E}">
+        <p14:creationId xmlns:p14="http://schemas.microsoft.com/office/powerpoint/2010/main" val="1333946847"/>
       </p:ext>
     </p:extLst>
   </p:cSld>

</xml_diff>